<commit_message>
update relazione e aggiunta matlab
</commit_message>
<xml_diff>
--- a/Documentazione.pptx
+++ b/Documentazione.pptx
@@ -3694,7 +3694,34 @@
                 </a:solidFill>
                 <a:latin typeface="NimbusRomNo9L-Regu"/>
               </a:rPr>
-              <a:t>l.pina4@campus.unimib.it, s.rancati8@campus.unimib.it</a:t>
+              <a:t>l.pina4@campus.unimib.it, </a:t>
+            </a:r>
+            <a:r>
+              <a:rPr lang="it-IT" sz="1500" b="1" dirty="0">
+                <a:solidFill>
+                  <a:srgbClr val="0000FF"/>
+                </a:solidFill>
+                <a:latin typeface="NimbusRomNo9L-Regu"/>
+                <a:hlinkClick r:id="rId5"/>
+              </a:rPr>
+              <a:t>s.rancati8@campus.unimib.it</a:t>
+            </a:r>
+            <a:endParaRPr lang="it-IT" sz="1500" b="1" dirty="0">
+              <a:solidFill>
+                <a:srgbClr val="0000FF"/>
+              </a:solidFill>
+              <a:latin typeface="NimbusRomNo9L-Regu"/>
+            </a:endParaRPr>
+          </a:p>
+          <a:p>
+            <a:r>
+              <a:rPr lang="it-IT" sz="1500" b="1" dirty="0">
+                <a:solidFill>
+                  <a:srgbClr val="0000FF"/>
+                </a:solidFill>
+                <a:latin typeface="NimbusRomNo9L-Regu"/>
+              </a:rPr>
+              <a:t>https://github.com/LorenzoPinaUnimib/InformaticaIndustriale</a:t>
             </a:r>
             <a:endParaRPr lang="it-IT" sz="1500" b="1" i="0" u="none" strike="noStrike" baseline="0" dirty="0">
               <a:solidFill>
@@ -3744,7 +3771,7 @@
           <p:nvPr/>
         </p:nvPicPr>
         <p:blipFill>
-          <a:blip r:embed="rId5">
+          <a:blip r:embed="rId6">
             <a:extLst>
               <a:ext uri="{28A0092B-C50C-407E-A947-70E740481C1C}">
                 <a14:useLocalDpi xmlns:a14="http://schemas.microsoft.com/office/drawing/2010/main" val="0"/>

</xml_diff>